<commit_message>
Corregir eyebrow/título duplicado en slide de cierre; verificar visualmente las 5 presentaciones con LibreOffice (63 slides sin defectos)
</commit_message>
<xml_diff>
--- a/clases/clase-2/presentacion.pptx
+++ b/clases/clase-2/presentacion.pptx
@@ -2561,7 +2561,7 @@
                 <a:ea typeface="Calibri" pitchFamily="34" charset="-122"/>
                 <a:cs typeface="Calibri" pitchFamily="34" charset="-120"/>
               </a:rPr>
-              <a:t>QUÉ LLEVARSE DE ESTA CLASE</a:t>
+              <a:t>CIERRE</a:t>
             </a:r>
             <a:endParaRPr lang="en-US" sz="1500" dirty="0"/>
           </a:p>
@@ -2600,7 +2600,7 @@
                 <a:ea typeface="Cambria" pitchFamily="34" charset="-122"/>
                 <a:cs typeface="Cambria" pitchFamily="34" charset="-120"/>
               </a:rPr>
-              <a:t>Qué llevarse de esta clase</a:t>
+              <a:t>SQL real, sin atajos</a:t>
             </a:r>
             <a:endParaRPr lang="en-US" sz="3000" dirty="0"/>
           </a:p>

</xml_diff>